<commit_message>
Auto-save: 2 file(s) — 2026-09-23 13:45
</commit_message>
<xml_diff>
--- a/Notes/2026-09-23-xloop-marketing-plan-q2-q3.pptx
+++ b/Notes/2026-09-23-xloop-marketing-plan-q2-q3.pptx
@@ -687,7 +687,7 @@
           <a:p>
             <a:r>
               <a:rPr lang="en-US" dirty="0"/>
-              <a:t>Sources: Marketing Q3 2026 report (Oct–Dec 2025 figures), Search Console Nov 2025 (227 of 232 clicks were brand searches), live sitemap (82 blog pages), Mari campaign results. The GA4 and Search Console accounts we can see today are set up for a different tracking ID and the non-www address, so they show no data. Fixing this is week 1.</a:t>
+              <a:t>Sources: GA4 (xLoop property, company account) and Search Console (www.xloopdigital.com), pulled 23 Sep 2026. 99% brand: of ~1,902 clicks, all but ~15 came from searches for xloop, x loop, xloop digital, xcelerate or x vision. GA4 recorded almost no traffic from about Jul 28 to Aug 23, so 90-day totals understate traffic; the 28-day figures are clean. Singapore shows 488 users in 28 days, close to Pakistan's 509. Likely bot traffic, worth filtering. 82 blog articles are live.</a:t>
             </a:r>
             <a:endParaRPr lang="en-US" dirty="0"/>
           </a:p>
@@ -2515,7 +2515,7 @@
                 <a:ea typeface="Arial" pitchFamily="34" charset="-122"/>
                 <a:cs typeface="Arial" pitchFamily="34" charset="-120"/>
               </a:rPr>
-              <a:t>An owner to connect analytics to the live site in week 1</a:t>
+              <a:t>Sales owner to confirm leads weekly, so we can report pipeline</a:t>
             </a:r>
             <a:endParaRPr lang="en-US" sz="1800" dirty="0"/>
           </a:p>
@@ -2625,7 +2625,7 @@
                 <a:ea typeface="Arial" pitchFamily="34" charset="-122"/>
                 <a:cs typeface="Arial" pitchFamily="34" charset="-120"/>
               </a:rPr>
-              <a:t>Last measured figures. Website numbers are from Oct–Dec 2025, the last period with working analytics</a:t>
+              <a:t>Google Analytics: last 28 days (Aug 26–Sep 22) · Search Console: last 3 months</a:t>
             </a:r>
             <a:endParaRPr lang="en-US" sz="1400" dirty="0"/>
           </a:p>
@@ -2691,7 +2691,7 @@
                 <a:ea typeface="Arial" pitchFamily="34" charset="-122"/>
                 <a:cs typeface="Arial" pitchFamily="34" charset="-120"/>
               </a:rPr>
-              <a:t>4.7k</a:t>
+              <a:t>1.4K</a:t>
             </a:r>
             <a:endParaRPr lang="en-US" sz="3400" dirty="0"/>
           </a:p>
@@ -2730,7 +2730,7 @@
                 <a:ea typeface="Arial" pitchFamily="34" charset="-122"/>
                 <a:cs typeface="Arial" pitchFamily="34" charset="-120"/>
               </a:rPr>
-              <a:t>Active website users in a quarter</a:t>
+              <a:t>Website users in the last 28 days (1.9K sessions)</a:t>
             </a:r>
             <a:endParaRPr lang="en-US" sz="1300" dirty="0"/>
           </a:p>
@@ -2796,7 +2796,7 @@
                 <a:ea typeface="Arial" pitchFamily="34" charset="-122"/>
                 <a:cs typeface="Arial" pitchFamily="34" charset="-120"/>
               </a:rPr>
-              <a:t>82</a:t>
+              <a:t>99%</a:t>
             </a:r>
             <a:endParaRPr lang="en-US" sz="3400" dirty="0"/>
           </a:p>
@@ -2835,7 +2835,7 @@
                 <a:ea typeface="Arial" pitchFamily="34" charset="-122"/>
                 <a:cs typeface="Arial" pitchFamily="34" charset="-120"/>
               </a:rPr>
-              <a:t>Articles published on the blog</a:t>
+              <a:t>Share of 1.9K Google clicks that came from people searching our name</a:t>
             </a:r>
             <a:endParaRPr lang="en-US" sz="1300" dirty="0"/>
           </a:p>
@@ -2901,7 +2901,7 @@
                 <a:ea typeface="Arial" pitchFamily="34" charset="-122"/>
                 <a:cs typeface="Arial" pitchFamily="34" charset="-120"/>
               </a:rPr>
-              <a:t>Page 9</a:t>
+              <a:t>~15</a:t>
             </a:r>
             <a:endParaRPr lang="en-US" sz="3400" dirty="0"/>
           </a:p>
@@ -2940,7 +2940,7 @@
                 <a:ea typeface="Arial" pitchFamily="34" charset="-122"/>
                 <a:cs typeface="Arial" pitchFamily="34" charset="-120"/>
               </a:rPr>
-              <a:t>Average Google position</a:t>
+              <a:t>Google clicks in 3 months from people who didn't search our name</a:t>
             </a:r>
             <a:endParaRPr lang="en-US" sz="1300" dirty="0"/>
           </a:p>
@@ -3006,7 +3006,7 @@
                 <a:ea typeface="Arial" pitchFamily="34" charset="-122"/>
                 <a:cs typeface="Arial" pitchFamily="34" charset="-120"/>
               </a:rPr>
-              <a:t>~0</a:t>
+              <a:t>Page 4</a:t>
             </a:r>
             <a:endParaRPr lang="en-US" sz="3400" dirty="0"/>
           </a:p>
@@ -3045,7 +3045,7 @@
                 <a:ea typeface="Arial" pitchFamily="34" charset="-122"/>
                 <a:cs typeface="Arial" pitchFamily="34" charset="-120"/>
               </a:rPr>
-              <a:t>Search clicks from people who didn't type "xLoop"</a:t>
+              <a:t>Average position for everything except our name (position 38)</a:t>
             </a:r>
             <a:endParaRPr lang="en-US" sz="1300" dirty="0"/>
           </a:p>
@@ -3111,7 +3111,7 @@
                 <a:ea typeface="Arial" pitchFamily="34" charset="-122"/>
                 <a:cs typeface="Arial" pitchFamily="34" charset="-120"/>
               </a:rPr>
-              <a:t>54</a:t>
+              <a:t>26</a:t>
             </a:r>
             <a:endParaRPr lang="en-US" sz="3400" dirty="0"/>
           </a:p>
@@ -3150,7 +3150,7 @@
                 <a:ea typeface="Arial" pitchFamily="34" charset="-122"/>
                 <a:cs typeface="Arial" pitchFamily="34" charset="-120"/>
               </a:rPr>
-              <a:t>Visits referred by ChatGPT in a quarter</a:t>
+              <a:t>Form submissions in 28 days. Client enquiries, jobs and training mixed together</a:t>
             </a:r>
             <a:endParaRPr lang="en-US" sz="1300" dirty="0"/>
           </a:p>
@@ -3210,13 +3210,13 @@
             <a:r>
               <a:rPr lang="en-US" sz="3400" b="1" dirty="0">
                 <a:solidFill>
-                  <a:srgbClr val="5CC3AE"/>
-                </a:solidFill>
-                <a:latin typeface="Arial" pitchFamily="34" charset="0"/>
-                <a:ea typeface="Arial" pitchFamily="34" charset="-122"/>
-                <a:cs typeface="Arial" pitchFamily="34" charset="-120"/>
-              </a:rPr>
-              <a:t>1,500</a:t>
+                  <a:srgbClr val="0061F6"/>
+                </a:solidFill>
+                <a:latin typeface="Arial" pitchFamily="34" charset="0"/>
+                <a:ea typeface="Arial" pitchFamily="34" charset="-122"/>
+                <a:cs typeface="Arial" pitchFamily="34" charset="-120"/>
+              </a:rPr>
+              <a:t>23</a:t>
             </a:r>
             <a:endParaRPr lang="en-US" sz="3400" dirty="0"/>
           </a:p>
@@ -3255,7 +3255,7 @@
                 <a:ea typeface="Arial" pitchFamily="34" charset="-122"/>
                 <a:cs typeface="Arial" pitchFamily="34" charset="-120"/>
               </a:rPr>
-              <a:t>Mari applications vs a 1,000 target (only paid campaign)</a:t>
+              <a:t>Visits from AI assistants (ChatGPT and others) in 30 days</a:t>
             </a:r>
             <a:endParaRPr lang="en-US" sz="1300" dirty="0"/>
           </a:p>
@@ -3321,7 +3321,7 @@
                 <a:ea typeface="Arial" pitchFamily="34" charset="-122"/>
                 <a:cs typeface="Arial" pitchFamily="34" charset="-120"/>
               </a:rPr>
-              <a:t>0</a:t>
+              <a:t>123</a:t>
             </a:r>
             <a:endParaRPr lang="en-US" sz="3400" dirty="0"/>
           </a:p>
@@ -3360,7 +3360,7 @@
                 <a:ea typeface="Arial" pitchFamily="34" charset="-122"/>
                 <a:cs typeface="Arial" pitchFamily="34" charset="-120"/>
               </a:rPr>
-              <a:t>Paid spend on lead generation. Pipeline is sales- and partner-led</a:t>
+              <a:t>Visits to "Page not found" in 30 days</a:t>
             </a:r>
             <a:endParaRPr lang="en-US" sz="1300" dirty="0"/>
           </a:p>
@@ -3420,13 +3420,13 @@
             <a:r>
               <a:rPr lang="en-US" sz="3400" b="1" dirty="0">
                 <a:solidFill>
-                  <a:srgbClr val="5A5A7A"/>
-                </a:solidFill>
-                <a:latin typeface="Arial" pitchFamily="34" charset="0"/>
-                <a:ea typeface="Arial" pitchFamily="34" charset="-122"/>
-                <a:cs typeface="Arial" pitchFamily="34" charset="-120"/>
-              </a:rPr>
-              <a:t>Not live</a:t>
+                  <a:srgbClr val="5CC3AE"/>
+                </a:solidFill>
+                <a:latin typeface="Arial" pitchFamily="34" charset="0"/>
+                <a:ea typeface="Arial" pitchFamily="34" charset="-122"/>
+                <a:cs typeface="Arial" pitchFamily="34" charset="-120"/>
+              </a:rPr>
+              <a:t>1,500</a:t>
             </a:r>
             <a:endParaRPr lang="en-US" sz="3400" dirty="0"/>
           </a:p>
@@ -3465,7 +3465,7 @@
                 <a:ea typeface="Arial" pitchFamily="34" charset="-122"/>
                 <a:cs typeface="Arial" pitchFamily="34" charset="-120"/>
               </a:rPr>
-              <a:t>Analytics we can access isn't connected to the live site</a:t>
+              <a:t>Mari applications vs a 1,000 target. Our only paid campaign</a:t>
             </a:r>
             <a:endParaRPr lang="en-US" sz="1300" dirty="0"/>
           </a:p>
@@ -3504,7 +3504,7 @@
                 <a:ea typeface="Arial" pitchFamily="34" charset="-122"/>
                 <a:cs typeface="Arial" pitchFamily="34" charset="-120"/>
               </a:rPr>
-              <a:t>We publish plenty. Search and AI engines don't yet send us buyers. Q2–Q3 closes that gap.</a:t>
+              <a:t>People who already know us find us. Buyers who don't, can't yet. Q2–Q3 closes that gap.</a:t>
             </a:r>
             <a:endParaRPr lang="en-US" sz="1600" dirty="0"/>
           </a:p>
@@ -6844,7 +6844,7 @@
                 <a:ea typeface="Arial" pitchFamily="34" charset="-122"/>
                 <a:cs typeface="Arial" pitchFamily="34" charset="-120"/>
               </a:rPr>
-              <a:t>82 articles, yet page 9 and ~0 non-brand clicks. Site signals are out of date: repeated page titles, and the profile AI engines read still lists industries we're dropping.</a:t>
+              <a:t>99% of Google clicks come from people searching our name. For everything else we sit on page 4, despite 82 articles. 123 visits a month land on "Page not found".</a:t>
             </a:r>
             <a:endParaRPr lang="en-US" sz="1300" dirty="0"/>
           </a:p>
@@ -7182,7 +7182,7 @@
                 <a:ea typeface="Arial" pitchFamily="34" charset="-122"/>
                 <a:cs typeface="Arial" pitchFamily="34" charset="-120"/>
               </a:rPr>
-              <a:t>No lead tracker, and analytics isn't connected to the live site. We can't show what marketing brings in.</a:t>
+              <a:t>86 form submissions in 90 days, with client enquiries, jobs and training mixed together. No record of which became deals. Analytics also missed about 4 weeks in Jul–Aug.</a:t>
             </a:r>
             <a:endParaRPr lang="en-US" sz="1300" dirty="0"/>
           </a:p>
@@ -8240,7 +8240,7 @@
                 <a:ea typeface="Arial" pitchFamily="34" charset="-122"/>
                 <a:cs typeface="Arial" pitchFamily="34" charset="-120"/>
               </a:rPr>
-              <a:t>Non-brand search clicks</a:t>
+              <a:t>Google clicks not from our name</a:t>
             </a:r>
             <a:endParaRPr lang="en-US" sz="1400" dirty="0"/>
           </a:p>
@@ -8279,7 +8279,7 @@
                 <a:ea typeface="Arial" pitchFamily="34" charset="-122"/>
                 <a:cs typeface="Arial" pitchFamily="34" charset="-120"/>
               </a:rPr>
-              <a:t>baseline ~0</a:t>
+              <a:t>baseline ~15 a quarter</a:t>
             </a:r>
             <a:endParaRPr lang="en-US" sz="1200" dirty="0"/>
           </a:p>
@@ -8382,7 +8382,7 @@
                 <a:ea typeface="Arial" pitchFamily="34" charset="-122"/>
                 <a:cs typeface="Arial" pitchFamily="34" charset="-120"/>
               </a:rPr>
-              <a:t>AI-engine referrals</a:t>
+              <a:t>Visits from AI assistants</a:t>
             </a:r>
             <a:endParaRPr lang="en-US" sz="1400" dirty="0"/>
           </a:p>
@@ -8421,7 +8421,7 @@
                 <a:ea typeface="Arial" pitchFamily="34" charset="-122"/>
                 <a:cs typeface="Arial" pitchFamily="34" charset="-120"/>
               </a:rPr>
-              <a:t>baseline 54 a quarter</a:t>
+              <a:t>baseline 23 a month</a:t>
             </a:r>
             <a:endParaRPr lang="en-US" sz="1200" dirty="0"/>
           </a:p>
@@ -8524,7 +8524,7 @@
                 <a:ea typeface="Arial" pitchFamily="34" charset="-122"/>
                 <a:cs typeface="Arial" pitchFamily="34" charset="-120"/>
               </a:rPr>
-              <a:t>Average Google position</a:t>
+              <a:t>Average position outside our name</a:t>
             </a:r>
             <a:endParaRPr lang="en-US" sz="1400" dirty="0"/>
           </a:p>
@@ -8563,7 +8563,7 @@
                 <a:ea typeface="Arial" pitchFamily="34" charset="-122"/>
                 <a:cs typeface="Arial" pitchFamily="34" charset="-120"/>
               </a:rPr>
-              <a:t>baseline page 9</a:t>
+              <a:t>baseline 38 (page 4)</a:t>
             </a:r>
             <a:endParaRPr lang="en-US" sz="1200" dirty="0"/>
           </a:p>
@@ -8602,7 +8602,7 @@
                 <a:ea typeface="Arial" pitchFamily="34" charset="-122"/>
                 <a:cs typeface="Arial" pitchFamily="34" charset="-120"/>
               </a:rPr>
-              <a:t>Baseline measured in October. Targets set in January, from real data.</a:t>
+              <a:t>Baselines are today's numbers. Targets set in January, after a full quarter on the new site.</a:t>
             </a:r>
             <a:endParaRPr lang="en-US" sz="1500" dirty="0"/>
           </a:p>
@@ -9121,7 +9121,7 @@
                 <a:ea typeface="Arial" pitchFamily="34" charset="-122"/>
                 <a:cs typeface="Arial" pitchFamily="34" charset="-120"/>
               </a:rPr>
-              <a:t>Fix analytics + lead tracker</a:t>
+              <a:t>Lead tracker + separate client forms from job forms</a:t>
             </a:r>
             <a:endParaRPr lang="en-US" sz="1100" dirty="0"/>
           </a:p>

</xml_diff>